<commit_message>
Deploying to gh-pages from @ tamanh-oxford/capacity-development@fba8f31d4e76349cc94ab17e9cccd98d0b097e4d 🚀
</commit_message>
<xml_diff>
--- a/data-management/index.pptx
+++ b/data-management/index.pptx
@@ -6113,7 +6113,7 @@
             </a:pPr>
             <a:r>
               <a:rPr/>
-              <a:t>Layers of data security</a:t>
+              <a:t>Layers of data security - Personal/individual layer</a:t>
             </a:r>
           </a:p>
         </p:txBody>
@@ -6136,7 +6136,7 @@
             <a:pPr lvl="0"/>
             <a:r>
               <a:rPr/>
-              <a:t>Personal/individual layer - us as individuals responsible for the security of our own personal information and any other information that we own or are responsible for.</a:t>
+              <a:t>Each one of us as individuals are responsible for the security of our own personal information and any other information that we own or are responsible for.</a:t>
             </a:r>
           </a:p>
         </p:txBody>
@@ -6230,7 +6230,7 @@
             </a:pPr>
             <a:r>
               <a:rPr/>
-              <a:t>Layers of data security</a:t>
+              <a:t>Layers of data security - Institutional layer</a:t>
             </a:r>
           </a:p>
         </p:txBody>
@@ -6253,25 +6253,18 @@
             <a:pPr lvl="0"/>
             <a:r>
               <a:rPr/>
-              <a:t>Institutional layer</a:t>
-            </a:r>
-          </a:p>
-          <a:p>
-            <a:pPr lvl="1"/>
-            <a:r>
-              <a:rPr/>
               <a:t>institutions responsible for the security of the personal information of its own employees and/or members/affiliates</a:t>
             </a:r>
           </a:p>
           <a:p>
-            <a:pPr lvl="1"/>
+            <a:pPr lvl="0"/>
             <a:r>
               <a:rPr/>
               <a:t>institutions responsible for the security of the personal information of others from whom they collect information from as part of the service they render.</a:t>
             </a:r>
           </a:p>
           <a:p>
-            <a:pPr lvl="1"/>
+            <a:pPr lvl="0"/>
             <a:r>
               <a:rPr/>
               <a:t>institutions responsible for the security of other types of information that they own or are responsible for</a:t>
@@ -6416,14 +6409,14 @@
             <a:pPr lvl="0"/>
             <a:r>
               <a:rPr/>
-              <a:t>Our choice of tools or the tools that we are made to use dictate how we implement the different steps in the data management pathway as such also influence the resulting quality of data that we obtain</a:t>
-            </a:r>
-          </a:p>
-          <a:p>
-            <a:pPr lvl="0"/>
-            <a:r>
-              <a:rPr/>
-              <a:t>Since every step of the data pathway used by the course participants involve Microsoft Excel, this tool has the greatest influence in the data quality of the current ecosystem of data in Seychelles</a:t>
+              <a:t>Our choice of tools or the tools that we are made to use dictate how we implement the different steps in the data management pathway</a:t>
+            </a:r>
+          </a:p>
+          <a:p>
+            <a:pPr lvl="0"/>
+            <a:r>
+              <a:rPr/>
+              <a:t>As such, our data tools also influence the resulting quality of data that we obtain</a:t>
             </a:r>
           </a:p>
         </p:txBody>
@@ -6957,7 +6950,7 @@
             <a:pPr lvl="0"/>
             <a:r>
               <a:rPr/>
-              <a:t>Do not use spaces in variables names and file anmes</a:t>
+              <a:t>Do not use spaces in variables names and file names</a:t>
             </a:r>
           </a:p>
           <a:p>

</xml_diff>